<commit_message>
docs: rewrite presentation — full sentences, clearer scale slide
Reworked both decks per feedback:
- Every slide now uses complete, plain-language sentences instead of
  terse fragments, so the presenter can read and understand each line.
- Removed internal implementation trivia the audience doesn't need
  (e.g. the caught-and-fixed bug, migration numbers).
- New two-column Scale slide that actually explains what "scale" means
  (what happens at 10k users), what's already built for growth
  (200-cap, pagination, indexes), and what would improve at scale
  (DB-side distance, SMS verification, the human-admin bottleneck).

Co-Authored-By: Claude Opus 4.8 (1M context) <noreply@anthropic.com>
</commit_message>
<xml_diff>
--- a/submission/en/iHelp-presentation.pptx
+++ b/submission/en/iHelp-presentation.pptx
@@ -3261,8 +3261,8 @@
         </p:nvSpPr>
         <p:spPr>
           <a:xfrm>
-            <a:off x="1371600" y="3794760"/>
-            <a:ext cx="9418320" cy="640080"/>
+            <a:off x="1188720" y="3794760"/>
+            <a:ext cx="9784080" cy="640080"/>
           </a:xfrm>
           <a:prstGeom prst="rect">
             <a:avLst/>
@@ -3290,7 +3290,7 @@
                 </a:solidFill>
                 <a:latin typeface="Calibri"/>
               </a:rPr>
-              <a:t>A reversed help-marketplace: post one request, verified neighbors compete to help</a:t>
+              <a:t>The reversed help-marketplace: post one request, and verified neighbors compete to help</a:t>
             </a:r>
           </a:p>
         </p:txBody>
@@ -3541,13 +3541,13 @@
               </a:spcAft>
             </a:pPr>
             <a:r>
-              <a:rPr sz="3400" b="1" lang="en-US">
+              <a:rPr sz="3200" b="1" lang="en-US">
                 <a:solidFill>
                   <a:srgbClr val="0E1F18"/>
                 </a:solidFill>
                 <a:latin typeface="Calibri"/>
               </a:rPr>
-              <a:t>How we thought about security</a:t>
+              <a:t>How we kept it secure</a:t>
             </a:r>
           </a:p>
         </p:txBody>
@@ -3560,7 +3560,7 @@
         </p:nvSpPr>
         <p:spPr>
           <a:xfrm>
-            <a:off x="548640" y="1481328"/>
+            <a:off x="548640" y="1463040"/>
             <a:ext cx="11064240" cy="31750"/>
           </a:xfrm>
           <a:prstGeom prst="rect">
@@ -3604,8 +3604,8 @@
         </p:nvSpPr>
         <p:spPr>
           <a:xfrm>
-            <a:off x="640080" y="1783080"/>
-            <a:ext cx="10881360" cy="3931920"/>
+            <a:off x="640080" y="1737360"/>
+            <a:ext cx="10881360" cy="3749039"/>
           </a:xfrm>
           <a:prstGeom prst="rect">
             <a:avLst/>
@@ -3623,17 +3623,17 @@
                 <a:spcPts val="0"/>
               </a:spcBef>
               <a:spcAft>
-                <a:spcPts val="1600"/>
-              </a:spcAft>
-            </a:pPr>
-            <a:r>
-              <a:rPr sz="1400" b="1">
+                <a:spcPts val="1500"/>
+              </a:spcAft>
+            </a:pPr>
+            <a:r>
+              <a:rPr sz="1300" b="1">
                 <a:solidFill>
                   <a:srgbClr val="0F6B4F"/>
                 </a:solidFill>
                 <a:latin typeface="Calibri"/>
               </a:rPr>
-              <a:t>●  </a:t>
+              <a:t>●   </a:t>
             </a:r>
             <a:r>
               <a:rPr sz="1800">
@@ -3642,7 +3642,7 @@
                 </a:solidFill>
                 <a:latin typeface="Calibri"/>
               </a:rPr>
-              <a:t>Four enforcement layers, only the last is trusted — the database.</a:t>
+              <a:t>Login is handled by Supabase — passwords are encrypted, and I never touch them directly.</a:t>
             </a:r>
           </a:p>
           <a:p>
@@ -3651,17 +3651,17 @@
                 <a:spcPts val="0"/>
               </a:spcBef>
               <a:spcAft>
-                <a:spcPts val="1600"/>
-              </a:spcAft>
-            </a:pPr>
-            <a:r>
-              <a:rPr sz="1400" b="1">
+                <a:spcPts val="1500"/>
+              </a:spcAft>
+            </a:pPr>
+            <a:r>
+              <a:rPr sz="1300" b="1">
                 <a:solidFill>
                   <a:srgbClr val="0F6B4F"/>
                 </a:solidFill>
                 <a:latin typeface="Calibri"/>
               </a:rPr>
-              <a:t>●  </a:t>
+              <a:t>●   </a:t>
             </a:r>
             <a:r>
               <a:rPr sz="1800">
@@ -3670,7 +3670,7 @@
                 </a:solidFill>
                 <a:latin typeface="Calibri"/>
               </a:rPr>
-              <a:t>Auth: Supabase Auth (bcrypt), HttpOnly cookies, JWT on every call.</a:t>
+              <a:t>Each user gets an encrypted 'ID card' (a JWT) sent with every action, so the database knows who they are.</a:t>
             </a:r>
           </a:p>
           <a:p>
@@ -3679,17 +3679,17 @@
                 <a:spcPts val="0"/>
               </a:spcBef>
               <a:spcAft>
-                <a:spcPts val="1600"/>
-              </a:spcAft>
-            </a:pPr>
-            <a:r>
-              <a:rPr sz="1400" b="1">
+                <a:spcPts val="1500"/>
+              </a:spcAft>
+            </a:pPr>
+            <a:r>
+              <a:rPr sz="1300" b="1">
                 <a:solidFill>
                   <a:srgbClr val="0F6B4F"/>
                 </a:solidFill>
                 <a:latin typeface="Calibri"/>
               </a:rPr>
-              <a:t>●  </a:t>
+              <a:t>●   </a:t>
             </a:r>
             <a:r>
               <a:rPr sz="1800">
@@ -3698,7 +3698,7 @@
                 </a:solidFill>
                 <a:latin typeface="Calibri"/>
               </a:rPr>
-              <a:t>The public anon key is safe because RLS is the authority · service-role in zero code.</a:t>
+              <a:t>All permissions are enforced in the database. Even if the site's public key leaks — it grants nothing beyond a normal user.</a:t>
             </a:r>
           </a:p>
           <a:p>
@@ -3707,17 +3707,17 @@
                 <a:spcPts val="0"/>
               </a:spcBef>
               <a:spcAft>
-                <a:spcPts val="1600"/>
-              </a:spcAft>
-            </a:pPr>
-            <a:r>
-              <a:rPr sz="1400" b="1">
+                <a:spcPts val="1500"/>
+              </a:spcAft>
+            </a:pPr>
+            <a:r>
+              <a:rPr sz="1300" b="1">
                 <a:solidFill>
                   <a:srgbClr val="0F6B4F"/>
                 </a:solidFill>
                 <a:latin typeface="Calibri"/>
               </a:rPr>
-              <a:t>●  </a:t>
+              <a:t>●   </a:t>
             </a:r>
             <a:r>
               <a:rPr sz="1800">
@@ -3726,7 +3726,7 @@
                 </a:solidFill>
                 <a:latin typeface="Calibri"/>
               </a:rPr>
-              <a:t>XSS · CSRF · SQL injection — all structurally neutralized.</a:t>
+              <a:t>The system is protected against the three common web attacks: XSS, CSRF, and SQL injection.</a:t>
             </a:r>
           </a:p>
         </p:txBody>
@@ -3739,8 +3739,8 @@
         </p:nvSpPr>
         <p:spPr>
           <a:xfrm>
-            <a:off x="640080" y="5623560"/>
-            <a:ext cx="10881360" cy="731520"/>
+            <a:off x="640080" y="5577840"/>
+            <a:ext cx="10881360" cy="777240"/>
           </a:xfrm>
           <a:prstGeom prst="roundRect">
             <a:avLst/>
@@ -3783,8 +3783,8 @@
         </p:nvSpPr>
         <p:spPr>
           <a:xfrm>
-            <a:off x="914400" y="5705856"/>
-            <a:ext cx="10332720" cy="566928"/>
+            <a:off x="914400" y="5650992"/>
+            <a:ext cx="10332720" cy="640080"/>
           </a:xfrm>
           <a:prstGeom prst="rect">
             <a:avLst/>
@@ -3806,13 +3806,13 @@
               </a:spcAft>
             </a:pPr>
             <a:r>
-              <a:rPr sz="1400" b="1" lang="en-US">
+              <a:rPr sz="1500" b="1" lang="en-US">
                 <a:solidFill>
                   <a:srgbClr val="0F6B4F"/>
                 </a:solidFill>
                 <a:latin typeface="Calibri"/>
               </a:rPr>
-              <a:t>An honest risk list (R1–R10), including a real bug caught and fixed.</a:t>
+              <a:t>I also honestly document the risks that remain and what I'd improve — because security is a process, not a checkbox.</a:t>
             </a:r>
           </a:p>
         </p:txBody>
@@ -3924,7 +3924,7 @@
                 </a:solidFill>
                 <a:latin typeface="Calibri"/>
               </a:rPr>
-              <a:t>§12 · Improvements</a:t>
+              <a:t>§12 · Future improvements</a:t>
             </a:r>
           </a:p>
         </p:txBody>
@@ -4002,13 +4002,13 @@
               </a:spcAft>
             </a:pPr>
             <a:r>
-              <a:rPr sz="3400" b="1" lang="en-US">
+              <a:rPr sz="3200" b="1" lang="en-US">
                 <a:solidFill>
                   <a:srgbClr val="0E1F18"/>
                 </a:solidFill>
                 <a:latin typeface="Calibri"/>
               </a:rPr>
-              <a:t>What we'd improve with more time</a:t>
+              <a:t>What I'd add with more time</a:t>
             </a:r>
           </a:p>
         </p:txBody>
@@ -4021,7 +4021,7 @@
         </p:nvSpPr>
         <p:spPr>
           <a:xfrm>
-            <a:off x="548640" y="1481328"/>
+            <a:off x="548640" y="1463040"/>
             <a:ext cx="11064240" cy="31750"/>
           </a:xfrm>
           <a:prstGeom prst="rect">
@@ -4065,8 +4065,8 @@
         </p:nvSpPr>
         <p:spPr>
           <a:xfrm>
-            <a:off x="640080" y="1783080"/>
-            <a:ext cx="10881360" cy="3931920"/>
+            <a:off x="640080" y="1737360"/>
+            <a:ext cx="10881360" cy="3749039"/>
           </a:xfrm>
           <a:prstGeom prst="rect">
             <a:avLst/>
@@ -4084,26 +4084,26 @@
                 <a:spcPts val="0"/>
               </a:spcBef>
               <a:spcAft>
-                <a:spcPts val="1800"/>
-              </a:spcAft>
-            </a:pPr>
-            <a:r>
-              <a:rPr sz="1600" b="1">
+                <a:spcPts val="1500"/>
+              </a:spcAft>
+            </a:pPr>
+            <a:r>
+              <a:rPr sz="1300" b="1">
                 <a:solidFill>
                   <a:srgbClr val="0F6B4F"/>
                 </a:solidFill>
                 <a:latin typeface="Calibri"/>
               </a:rPr>
-              <a:t>●  </a:t>
-            </a:r>
-            <a:r>
-              <a:rPr sz="2000">
+              <a:t>●   </a:t>
+            </a:r>
+            <a:r>
+              <a:rPr sz="1800">
                 <a:solidFill>
                   <a:srgbClr val="0E1F18"/>
                 </a:solidFill>
                 <a:latin typeface="Calibri"/>
               </a:rPr>
-              <a:t>In-app chat between the matched parties.</a:t>
+              <a:t>In-app chat — today the two sides exchange phone numbers and coordinate outside.</a:t>
             </a:r>
           </a:p>
           <a:p>
@@ -4112,26 +4112,26 @@
                 <a:spcPts val="0"/>
               </a:spcBef>
               <a:spcAft>
-                <a:spcPts val="1800"/>
-              </a:spcAft>
-            </a:pPr>
-            <a:r>
-              <a:rPr sz="1600" b="1">
+                <a:spcPts val="1500"/>
+              </a:spcAft>
+            </a:pPr>
+            <a:r>
+              <a:rPr sz="1300" b="1">
                 <a:solidFill>
                   <a:srgbClr val="0F6B4F"/>
                 </a:solidFill>
                 <a:latin typeface="Calibri"/>
               </a:rPr>
-              <a:t>●  </a:t>
-            </a:r>
-            <a:r>
-              <a:rPr sz="2000">
+              <a:t>●   </a:t>
+            </a:r>
+            <a:r>
+              <a:rPr sz="1800">
                 <a:solidFill>
                   <a:srgbClr val="0E1F18"/>
                 </a:solidFill>
                 <a:latin typeface="Calibri"/>
               </a:rPr>
-              <a:t>SMS OTP for real phone verification.</a:t>
+              <a:t>Real phone verification via SMS — to strengthen the identity check.</a:t>
             </a:r>
           </a:p>
           <a:p>
@@ -4140,26 +4140,26 @@
                 <a:spcPts val="0"/>
               </a:spcBef>
               <a:spcAft>
-                <a:spcPts val="1800"/>
-              </a:spcAft>
-            </a:pPr>
-            <a:r>
-              <a:rPr sz="1600" b="1">
+                <a:spcPts val="1500"/>
+              </a:spcAft>
+            </a:pPr>
+            <a:r>
+              <a:rPr sz="1300" b="1">
                 <a:solidFill>
                   <a:srgbClr val="0F6B4F"/>
                 </a:solidFill>
                 <a:latin typeface="Calibri"/>
               </a:rPr>
-              <a:t>●  </a:t>
-            </a:r>
-            <a:r>
-              <a:rPr sz="2000">
+              <a:t>●   </a:t>
+            </a:r>
+            <a:r>
+              <a:rPr sz="1800">
                 <a:solidFill>
                   <a:srgbClr val="0E1F18"/>
                 </a:solidFill>
                 <a:latin typeface="Calibri"/>
               </a:rPr>
-              <a:t>In-app notifications — no manual refresh.</a:t>
+              <a:t>Notifications — so a user knows a new offer arrived without refreshing.</a:t>
             </a:r>
           </a:p>
           <a:p>
@@ -4168,26 +4168,26 @@
                 <a:spcPts val="0"/>
               </a:spcBef>
               <a:spcAft>
-                <a:spcPts val="1800"/>
-              </a:spcAft>
-            </a:pPr>
-            <a:r>
-              <a:rPr sz="1600" b="1">
+                <a:spcPts val="1500"/>
+              </a:spcAft>
+            </a:pPr>
+            <a:r>
+              <a:rPr sz="1300" b="1">
                 <a:solidFill>
                   <a:srgbClr val="0F6B4F"/>
                 </a:solidFill>
                 <a:latin typeface="Calibri"/>
               </a:rPr>
-              <a:t>●  </a:t>
-            </a:r>
-            <a:r>
-              <a:rPr sz="2000">
+              <a:t>●   </a:t>
+            </a:r>
+            <a:r>
+              <a:rPr sz="1800">
                 <a:solidFill>
                   <a:srgbClr val="0E1F18"/>
                 </a:solidFill>
                 <a:latin typeface="Calibri"/>
               </a:rPr>
-              <a:t>Requester-side reputation — closing the trust symmetry.</a:t>
+              <a:t>Ratings for requesters too — so helpers also know who they're coming to help.</a:t>
             </a:r>
           </a:p>
         </p:txBody>
@@ -4200,8 +4200,8 @@
         </p:nvSpPr>
         <p:spPr>
           <a:xfrm>
-            <a:off x="640080" y="5623560"/>
-            <a:ext cx="10881360" cy="731520"/>
+            <a:off x="640080" y="5577840"/>
+            <a:ext cx="10881360" cy="777240"/>
           </a:xfrm>
           <a:prstGeom prst="roundRect">
             <a:avLst/>
@@ -4244,8 +4244,8 @@
         </p:nvSpPr>
         <p:spPr>
           <a:xfrm>
-            <a:off x="914400" y="5705856"/>
-            <a:ext cx="10332720" cy="566928"/>
+            <a:off x="914400" y="5650992"/>
+            <a:ext cx="10332720" cy="640080"/>
           </a:xfrm>
           <a:prstGeom prst="rect">
             <a:avLst/>
@@ -4267,13 +4267,13 @@
               </a:spcAft>
             </a:pPr>
             <a:r>
-              <a:rPr sz="1400" b="1" lang="en-US">
+              <a:rPr sz="1500" b="1" lang="en-US">
                 <a:solidFill>
                   <a:srgbClr val="0F6B4F"/>
                 </a:solidFill>
                 <a:latin typeface="Calibri"/>
               </a:rPr>
-              <a:t>All were deliberate cuts — a small, clean, secure MVP.</a:t>
+              <a:t>All of these were left out on purpose. I preferred a small, clean, secure product over a big, unstable one.</a:t>
             </a:r>
           </a:p>
         </p:txBody>
@@ -4356,7 +4356,7 @@
         </p:nvSpPr>
         <p:spPr>
           <a:xfrm>
-            <a:off x="914400" y="1417320"/>
+            <a:off x="914400" y="1371600"/>
             <a:ext cx="10332720" cy="502920"/>
           </a:xfrm>
           <a:prstGeom prst="rect">
@@ -4398,7 +4398,7 @@
         </p:nvSpPr>
         <p:spPr>
           <a:xfrm>
-            <a:off x="1280160" y="2148840"/>
+            <a:off x="1280160" y="2103120"/>
             <a:ext cx="9601200" cy="2011680"/>
           </a:xfrm>
           <a:prstGeom prst="rect">
@@ -4421,13 +4421,13 @@
               </a:spcAft>
             </a:pPr>
             <a:r>
-              <a:rPr sz="2500" b="1" lang="en-US">
+              <a:rPr sz="2300" b="1" lang="en-US">
                 <a:solidFill>
                   <a:srgbClr val="FFFFFF"/>
                 </a:solidFill>
                 <a:latin typeface="Calibri"/>
               </a:rPr>
-              <a:t>iHelp reverses the search for help — you post once and verified neighbors compete to help you — and every line is built so the database itself enforces trust.</a:t>
+              <a:t>iHelp reverses the search for help: you post once, and verified neighbors compete to help you. And every line is built so the database itself enforces trust.</a:t>
             </a:r>
           </a:p>
         </p:txBody>
@@ -4440,7 +4440,7 @@
         </p:nvSpPr>
         <p:spPr>
           <a:xfrm>
-            <a:off x="914400" y="4160520"/>
+            <a:off x="914400" y="4206240"/>
             <a:ext cx="10332720" cy="640080"/>
           </a:xfrm>
           <a:prstGeom prst="rect">
@@ -4530,7 +4530,7 @@
                 </a:solidFill>
                 <a:latin typeface="Calibri"/>
               </a:rPr>
-              <a:t>Thank you — questions?</a:t>
+              <a:t>Thank you — I'd love your questions</a:t>
             </a:r>
           </a:p>
         </p:txBody>
@@ -4720,13 +4720,13 @@
               </a:spcAft>
             </a:pPr>
             <a:r>
-              <a:rPr sz="3400" b="1" lang="en-US">
+              <a:rPr sz="3200" b="1" lang="en-US">
                 <a:solidFill>
                   <a:srgbClr val="0E1F18"/>
                 </a:solidFill>
                 <a:latin typeface="Calibri"/>
               </a:rPr>
-              <a:t>The problem: help is slow and one-directional</a:t>
+              <a:t>The problem: finding trustworthy help is slow</a:t>
             </a:r>
           </a:p>
         </p:txBody>
@@ -4739,7 +4739,7 @@
         </p:nvSpPr>
         <p:spPr>
           <a:xfrm>
-            <a:off x="548640" y="1481328"/>
+            <a:off x="548640" y="1463040"/>
             <a:ext cx="11064240" cy="31750"/>
           </a:xfrm>
           <a:prstGeom prst="rect">
@@ -4783,8 +4783,8 @@
         </p:nvSpPr>
         <p:spPr>
           <a:xfrm>
-            <a:off x="640080" y="1783080"/>
-            <a:ext cx="10881360" cy="3931920"/>
+            <a:off x="640080" y="1737360"/>
+            <a:ext cx="10881360" cy="3749039"/>
           </a:xfrm>
           <a:prstGeom prst="rect">
             <a:avLst/>
@@ -4802,26 +4802,26 @@
                 <a:spcPts val="0"/>
               </a:spcBef>
               <a:spcAft>
-                <a:spcPts val="2000"/>
-              </a:spcAft>
-            </a:pPr>
-            <a:r>
-              <a:rPr sz="1600" b="1">
+                <a:spcPts val="1500"/>
+              </a:spcAft>
+            </a:pPr>
+            <a:r>
+              <a:rPr sz="1300" b="1">
                 <a:solidFill>
                   <a:srgbClr val="0F6B4F"/>
                 </a:solidFill>
                 <a:latin typeface="Calibri"/>
               </a:rPr>
-              <a:t>●  </a:t>
-            </a:r>
-            <a:r>
-              <a:rPr sz="2000">
+              <a:t>●   </a:t>
+            </a:r>
+            <a:r>
+              <a:rPr sz="1800">
                 <a:solidFill>
                   <a:srgbClr val="0E1F18"/>
                 </a:solidFill>
                 <a:latin typeface="Calibri"/>
               </a:rPr>
-              <a:t>You search, compare, and call providers one by one — they can't even see the demand.</a:t>
+              <a:t>When you need help, you search alone: calling provider after provider, comparing, waiting for callbacks. It's slow and exhausting.</a:t>
             </a:r>
           </a:p>
           <a:p>
@@ -4830,26 +4830,26 @@
                 <a:spcPts val="0"/>
               </a:spcBef>
               <a:spcAft>
-                <a:spcPts val="2000"/>
-              </a:spcAft>
-            </a:pPr>
-            <a:r>
-              <a:rPr sz="1600" b="1">
+                <a:spcPts val="1500"/>
+              </a:spcAft>
+            </a:pPr>
+            <a:r>
+              <a:rPr sz="1300" b="1">
                 <a:solidFill>
                   <a:srgbClr val="0F6B4F"/>
                 </a:solidFill>
                 <a:latin typeface="Calibri"/>
               </a:rPr>
-              <a:t>●  </a:t>
-            </a:r>
-            <a:r>
-              <a:rPr sz="2000">
+              <a:t>●   </a:t>
+            </a:r>
+            <a:r>
+              <a:rPr sz="1800">
                 <a:solidFill>
                   <a:srgbClr val="0E1F18"/>
                 </a:solidFill>
                 <a:latin typeface="Calibri"/>
               </a:rPr>
-              <a:t>Trust is expensive, and must run both ways — a fake requester endangers a helper too.</a:t>
+              <a:t>It's hard to know who to trust. Anyone can claim to be a professional, and there's nowhere to check.</a:t>
             </a:r>
           </a:p>
           <a:p>
@@ -4858,26 +4858,26 @@
                 <a:spcPts val="0"/>
               </a:spcBef>
               <a:spcAft>
-                <a:spcPts val="2000"/>
-              </a:spcAft>
-            </a:pPr>
-            <a:r>
-              <a:rPr sz="1600" b="1">
+                <a:spcPts val="1500"/>
+              </a:spcAft>
+            </a:pPr>
+            <a:r>
+              <a:rPr sz="1300" b="1">
                 <a:solidFill>
                   <a:srgbClr val="0F6B4F"/>
                 </a:solidFill>
                 <a:latin typeface="Calibri"/>
               </a:rPr>
-              <a:t>●  </a:t>
-            </a:r>
-            <a:r>
-              <a:rPr sz="2000">
+              <a:t>●   </a:t>
+            </a:r>
+            <a:r>
+              <a:rPr sz="1800">
                 <a:solidFill>
                   <a:srgbClr val="0E1F18"/>
                 </a:solidFill>
                 <a:latin typeface="Calibri"/>
               </a:rPr>
-              <a:t>Availability is opaque — who's free and near right now? Which requests are open?</a:t>
+              <a:t>The helper is at risk too: they walk into a stranger's home without knowing who called them.</a:t>
             </a:r>
           </a:p>
           <a:p>
@@ -4886,26 +4886,26 @@
                 <a:spcPts val="0"/>
               </a:spcBef>
               <a:spcAft>
-                <a:spcPts val="2000"/>
-              </a:spcAft>
-            </a:pPr>
-            <a:r>
-              <a:rPr sz="1600" b="1">
+                <a:spcPts val="1500"/>
+              </a:spcAft>
+            </a:pPr>
+            <a:r>
+              <a:rPr sz="1300" b="1">
                 <a:solidFill>
                   <a:srgbClr val="0F6B4F"/>
                 </a:solidFill>
                 <a:latin typeface="Calibri"/>
               </a:rPr>
-              <a:t>●  </a:t>
-            </a:r>
-            <a:r>
-              <a:rPr sz="2000">
+              <a:t>●   </a:t>
+            </a:r>
+            <a:r>
+              <a:rPr sz="1800">
                 <a:solidFill>
                   <a:srgbClr val="0E1F18"/>
                 </a:solidFill>
                 <a:latin typeface="Calibri"/>
               </a:rPr>
-              <a:t>Small, volunteer-suitable tasks fall through the cracks.</a:t>
+              <a:t>Small tasks — a ride, help with a form, moving furniture — fall through the cracks, with no channel connecting people.</a:t>
             </a:r>
           </a:p>
         </p:txBody>
@@ -4918,8 +4918,8 @@
         </p:nvSpPr>
         <p:spPr>
           <a:xfrm>
-            <a:off x="640080" y="5623560"/>
-            <a:ext cx="10881360" cy="731520"/>
+            <a:off x="640080" y="5577840"/>
+            <a:ext cx="10881360" cy="777240"/>
           </a:xfrm>
           <a:prstGeom prst="roundRect">
             <a:avLst/>
@@ -4962,8 +4962,8 @@
         </p:nvSpPr>
         <p:spPr>
           <a:xfrm>
-            <a:off x="914400" y="5705856"/>
-            <a:ext cx="10332720" cy="566928"/>
+            <a:off x="914400" y="5650992"/>
+            <a:ext cx="10332720" cy="640080"/>
           </a:xfrm>
           <a:prstGeom prst="rect">
             <a:avLst/>
@@ -4985,13 +4985,13 @@
               </a:spcAft>
             </a:pPr>
             <a:r>
-              <a:rPr sz="1400" b="1" lang="en-US">
+              <a:rPr sz="1500" b="1" lang="en-US">
                 <a:solidFill>
                   <a:srgbClr val="0F6B4F"/>
                 </a:solidFill>
                 <a:latin typeface="Calibri"/>
               </a:rPr>
-              <a:t>iHelp reverses it: demand is published once, and supply comes to it.</a:t>
+              <a:t>iHelp flips the direction: instead of you searching for help, you post one request — and the help comes to you.</a:t>
             </a:r>
           </a:p>
         </p:txBody>
@@ -5181,13 +5181,13 @@
               </a:spcAft>
             </a:pPr>
             <a:r>
-              <a:rPr sz="3400" b="1" lang="en-US">
+              <a:rPr sz="3200" b="1" lang="en-US">
                 <a:solidFill>
                   <a:srgbClr val="0E1F18"/>
                 </a:solidFill>
                 <a:latin typeface="Calibri"/>
               </a:rPr>
-              <a:t>The solution: a reversed marketplace</a:t>
+              <a:t>The solution: post once, get helped</a:t>
             </a:r>
           </a:p>
         </p:txBody>
@@ -5200,7 +5200,7 @@
         </p:nvSpPr>
         <p:spPr>
           <a:xfrm>
-            <a:off x="548640" y="1481328"/>
+            <a:off x="548640" y="1463040"/>
             <a:ext cx="11064240" cy="31750"/>
           </a:xfrm>
           <a:prstGeom prst="rect">
@@ -5244,8 +5244,8 @@
         </p:nvSpPr>
         <p:spPr>
           <a:xfrm>
-            <a:off x="640080" y="1783080"/>
-            <a:ext cx="10881360" cy="3931920"/>
+            <a:off x="640080" y="1737360"/>
+            <a:ext cx="10881360" cy="3749039"/>
           </a:xfrm>
           <a:prstGeom prst="rect">
             <a:avLst/>
@@ -5263,26 +5263,26 @@
                 <a:spcPts val="0"/>
               </a:spcBef>
               <a:spcAft>
-                <a:spcPts val="1800"/>
-              </a:spcAft>
-            </a:pPr>
-            <a:r>
-              <a:rPr sz="1600" b="1">
+                <a:spcPts val="1500"/>
+              </a:spcAft>
+            </a:pPr>
+            <a:r>
+              <a:rPr sz="1300" b="1">
                 <a:solidFill>
                   <a:srgbClr val="0F6B4F"/>
                 </a:solidFill>
                 <a:latin typeface="Calibri"/>
               </a:rPr>
-              <a:t>●  </a:t>
-            </a:r>
-            <a:r>
-              <a:rPr sz="2000">
+              <a:t>●   </a:t>
+            </a:r>
+            <a:r>
+              <a:rPr sz="1800">
                 <a:solidFill>
                   <a:srgbClr val="0E1F18"/>
                 </a:solidFill>
                 <a:latin typeface="Calibri"/>
               </a:rPr>
-              <a:t>A requester posts one request — title, description, category, photos, location.</a:t>
+              <a:t>The requester posts one help request — with a title, description, category, and a location on the map.</a:t>
             </a:r>
           </a:p>
           <a:p>
@@ -5291,26 +5291,26 @@
                 <a:spcPts val="0"/>
               </a:spcBef>
               <a:spcAft>
-                <a:spcPts val="1800"/>
-              </a:spcAft>
-            </a:pPr>
-            <a:r>
-              <a:rPr sz="1600" b="1">
+                <a:spcPts val="1500"/>
+              </a:spcAft>
+            </a:pPr>
+            <a:r>
+              <a:rPr sz="1300" b="1">
                 <a:solidFill>
                   <a:srgbClr val="0F6B4F"/>
                 </a:solidFill>
                 <a:latin typeface="Calibri"/>
               </a:rPr>
-              <a:t>●  </a:t>
-            </a:r>
-            <a:r>
-              <a:rPr sz="2000">
+              <a:t>●   </a:t>
+            </a:r>
+            <a:r>
+              <a:rPr sz="1800">
                 <a:solidFill>
                   <a:srgbClr val="0E1F18"/>
                 </a:solidFill>
                 <a:latin typeface="Calibri"/>
               </a:rPr>
-              <a:t>Verified helpers compete with offers — pricing is theirs: fixed / volunteer / after-job.</a:t>
+              <a:t>Verified helpers nearby see it and submit offers. They set the price: paid, volunteer, or priced at the end.</a:t>
             </a:r>
           </a:p>
           <a:p>
@@ -5319,26 +5319,26 @@
                 <a:spcPts val="0"/>
               </a:spcBef>
               <a:spcAft>
-                <a:spcPts val="1800"/>
-              </a:spcAft>
-            </a:pPr>
-            <a:r>
-              <a:rPr sz="1600" b="1">
+                <a:spcPts val="1500"/>
+              </a:spcAft>
+            </a:pPr>
+            <a:r>
+              <a:rPr sz="1300" b="1">
                 <a:solidFill>
                   <a:srgbClr val="0F6B4F"/>
                 </a:solidFill>
                 <a:latin typeface="Calibri"/>
               </a:rPr>
-              <a:t>●  </a:t>
-            </a:r>
-            <a:r>
-              <a:rPr sz="2000">
+              <a:t>●   </a:t>
+            </a:r>
+            <a:r>
+              <a:rPr sz="1800">
                 <a:solidFill>
                   <a:srgbClr val="0E1F18"/>
                 </a:solidFill>
                 <a:latin typeface="Calibri"/>
               </a:rPr>
-              <a:t>The requester compares and picks one offer — all others close automatically.</a:t>
+              <a:t>The requester sees all offers side by side and picks one. All the others close automatically.</a:t>
             </a:r>
           </a:p>
           <a:p>
@@ -5347,26 +5347,26 @@
                 <a:spcPts val="0"/>
               </a:spcBef>
               <a:spcAft>
-                <a:spcPts val="1800"/>
-              </a:spcAft>
-            </a:pPr>
-            <a:r>
-              <a:rPr sz="1600" b="1">
+                <a:spcPts val="1500"/>
+              </a:spcAft>
+            </a:pPr>
+            <a:r>
+              <a:rPr sz="1300" b="1">
                 <a:solidFill>
                   <a:srgbClr val="0F6B4F"/>
                 </a:solidFill>
                 <a:latin typeface="Calibri"/>
               </a:rPr>
-              <a:t>●  </a:t>
-            </a:r>
-            <a:r>
-              <a:rPr sz="2000">
+              <a:t>●   </a:t>
+            </a:r>
+            <a:r>
+              <a:rPr sz="1800">
                 <a:solidFill>
                   <a:srgbClr val="0E1F18"/>
                 </a:solidFill>
                 <a:latin typeface="Calibri"/>
               </a:rPr>
-              <a:t>Both sides confirm completion, and the requester rates the helper.</a:t>
+              <a:t>Finally, both sides confirm the work is done, and the requester rates the helper.</a:t>
             </a:r>
           </a:p>
         </p:txBody>
@@ -5379,8 +5379,8 @@
         </p:nvSpPr>
         <p:spPr>
           <a:xfrm>
-            <a:off x="640080" y="5623560"/>
-            <a:ext cx="10881360" cy="731520"/>
+            <a:off x="640080" y="5577840"/>
+            <a:ext cx="10881360" cy="777240"/>
           </a:xfrm>
           <a:prstGeom prst="roundRect">
             <a:avLst/>
@@ -5423,8 +5423,8 @@
         </p:nvSpPr>
         <p:spPr>
           <a:xfrm>
-            <a:off x="914400" y="5705856"/>
-            <a:ext cx="10332720" cy="566928"/>
+            <a:off x="914400" y="5650992"/>
+            <a:ext cx="10332720" cy="640080"/>
           </a:xfrm>
           <a:prstGeom prst="rect">
             <a:avLst/>
@@ -5446,13 +5446,13 @@
               </a:spcAft>
             </a:pPr>
             <a:r>
-              <a:rPr sz="1400" b="1" lang="en-US">
+              <a:rPr sz="1500" b="1" lang="en-US">
                 <a:solidFill>
                   <a:srgbClr val="0F6B4F"/>
                 </a:solidFill>
                 <a:latin typeface="Calibri"/>
               </a:rPr>
-              <a:t>The reversal is the whole idea — and every rule is enforced by the database.</a:t>
+              <a:t>This reversal is the whole idea — instead of demand chasing supply, supply comes to demand.</a:t>
             </a:r>
           </a:p>
         </p:txBody>
@@ -5564,7 +5564,7 @@
                 </a:solidFill>
                 <a:latin typeface="Calibri"/>
               </a:rPr>
-              <a:t>§3–4 · Users &amp; value</a:t>
+              <a:t>§3–4 · Users &amp; business value</a:t>
             </a:r>
           </a:p>
         </p:txBody>
@@ -5642,13 +5642,13 @@
               </a:spcAft>
             </a:pPr>
             <a:r>
-              <a:rPr sz="3400" b="1" lang="en-US">
+              <a:rPr sz="3200" b="1" lang="en-US">
                 <a:solidFill>
                   <a:srgbClr val="0E1F18"/>
                 </a:solidFill>
                 <a:latin typeface="Calibri"/>
               </a:rPr>
-              <a:t>Users, customer, and business value</a:t>
+              <a:t>Who uses it, and where the money comes from</a:t>
             </a:r>
           </a:p>
         </p:txBody>
@@ -5661,7 +5661,7 @@
         </p:nvSpPr>
         <p:spPr>
           <a:xfrm>
-            <a:off x="548640" y="1481328"/>
+            <a:off x="548640" y="1463040"/>
             <a:ext cx="11064240" cy="31750"/>
           </a:xfrm>
           <a:prstGeom prst="rect">
@@ -5705,8 +5705,8 @@
         </p:nvSpPr>
         <p:spPr>
           <a:xfrm>
-            <a:off x="640080" y="1783080"/>
-            <a:ext cx="10881360" cy="3931920"/>
+            <a:off x="640080" y="1737360"/>
+            <a:ext cx="10881360" cy="3749039"/>
           </a:xfrm>
           <a:prstGeom prst="rect">
             <a:avLst/>
@@ -5724,26 +5724,26 @@
                 <a:spcPts val="0"/>
               </a:spcBef>
               <a:spcAft>
-                <a:spcPts val="1800"/>
-              </a:spcAft>
-            </a:pPr>
-            <a:r>
-              <a:rPr sz="1600" b="1">
+                <a:spcPts val="1500"/>
+              </a:spcAft>
+            </a:pPr>
+            <a:r>
+              <a:rPr sz="1300" b="1">
                 <a:solidFill>
                   <a:srgbClr val="0F6B4F"/>
                 </a:solidFill>
                 <a:latin typeface="Calibri"/>
               </a:rPr>
-              <a:t>●  </a:t>
-            </a:r>
-            <a:r>
-              <a:rPr sz="2000">
+              <a:t>●   </a:t>
+            </a:r>
+            <a:r>
+              <a:rPr sz="1800">
                 <a:solidFill>
                   <a:srgbClr val="0E1F18"/>
                 </a:solidFill>
                 <a:latin typeface="Calibri"/>
               </a:rPr>
-              <a:t>One account, many hats — permissions are per-row, not per-account.</a:t>
+              <a:t>There's one account type. The same person can request help in the morning and help someone else at night.</a:t>
             </a:r>
           </a:p>
           <a:p>
@@ -5752,26 +5752,26 @@
                 <a:spcPts val="0"/>
               </a:spcBef>
               <a:spcAft>
-                <a:spcPts val="1800"/>
-              </a:spcAft>
-            </a:pPr>
-            <a:r>
-              <a:rPr sz="1600" b="1">
+                <a:spcPts val="1500"/>
+              </a:spcAft>
+            </a:pPr>
+            <a:r>
+              <a:rPr sz="1300" b="1">
                 <a:solidFill>
                   <a:srgbClr val="0F6B4F"/>
                 </a:solidFill>
                 <a:latin typeface="Calibri"/>
               </a:rPr>
-              <a:t>●  </a:t>
-            </a:r>
-            <a:r>
-              <a:rPr sz="2000">
+              <a:t>●   </a:t>
+            </a:r>
+            <a:r>
+              <a:rPr sz="1800">
                 <a:solidFill>
                   <a:srgbClr val="0E1F18"/>
                 </a:solidFill>
                 <a:latin typeface="Calibri"/>
               </a:rPr>
-              <a:t>Three roles: requester · verified helper (optional pro badge) · admin.</a:t>
+              <a:t>Three roles: a requester, a verified helper (with an optional 'professional' badge), and an admin who approves users.</a:t>
             </a:r>
           </a:p>
           <a:p>
@@ -5780,26 +5780,26 @@
                 <a:spcPts val="0"/>
               </a:spcBef>
               <a:spcAft>
-                <a:spcPts val="1800"/>
-              </a:spcAft>
-            </a:pPr>
-            <a:r>
-              <a:rPr sz="1600" b="1">
+                <a:spcPts val="1500"/>
+              </a:spcAft>
+            </a:pPr>
+            <a:r>
+              <a:rPr sz="1300" b="1">
                 <a:solidFill>
                   <a:srgbClr val="0F6B4F"/>
                 </a:solidFill>
                 <a:latin typeface="Calibri"/>
               </a:rPr>
-              <a:t>●  </a:t>
-            </a:r>
-            <a:r>
-              <a:rPr sz="2000">
+              <a:t>●   </a:t>
+            </a:r>
+            <a:r>
+              <a:rPr sz="1800">
                 <a:solidFill>
                   <a:srgbClr val="0E1F18"/>
                 </a:solidFill>
                 <a:latin typeface="Calibri"/>
               </a:rPr>
-              <a:t>The customer = the professional helper. iHelp is a lead-generation channel.</a:t>
+              <a:t>Requesters don't pay — on purpose. Charging them would mean fewer requests, and then there's no one to help.</a:t>
             </a:r>
           </a:p>
           <a:p>
@@ -5808,26 +5808,26 @@
                 <a:spcPts val="0"/>
               </a:spcBef>
               <a:spcAft>
-                <a:spcPts val="1800"/>
-              </a:spcAft>
-            </a:pPr>
-            <a:r>
-              <a:rPr sz="1600" b="1">
+                <a:spcPts val="1500"/>
+              </a:spcAft>
+            </a:pPr>
+            <a:r>
+              <a:rPr sz="1300" b="1">
                 <a:solidFill>
                   <a:srgbClr val="0F6B4F"/>
                 </a:solidFill>
                 <a:latin typeface="Calibri"/>
               </a:rPr>
-              <a:t>●  </a:t>
-            </a:r>
-            <a:r>
-              <a:rPr sz="2000">
+              <a:t>●   </a:t>
+            </a:r>
+            <a:r>
+              <a:rPr sz="1800">
                 <a:solidFill>
                   <a:srgbClr val="0E1F18"/>
                 </a:solidFill>
                 <a:latin typeface="Calibri"/>
               </a:rPr>
-              <a:t>Requesters are free by design — charging demand would kill liquidity.</a:t>
+              <a:t>The money comes from professional helpers: iHelp brings them nearby customers who already need a service.</a:t>
             </a:r>
           </a:p>
         </p:txBody>
@@ -5840,8 +5840,8 @@
         </p:nvSpPr>
         <p:spPr>
           <a:xfrm>
-            <a:off x="640080" y="5623560"/>
-            <a:ext cx="10881360" cy="731520"/>
+            <a:off x="640080" y="5577840"/>
+            <a:ext cx="10881360" cy="777240"/>
           </a:xfrm>
           <a:prstGeom prst="roundRect">
             <a:avLst/>
@@ -5884,8 +5884,8 @@
         </p:nvSpPr>
         <p:spPr>
           <a:xfrm>
-            <a:off x="914400" y="5705856"/>
-            <a:ext cx="10332720" cy="566928"/>
+            <a:off x="914400" y="5650992"/>
+            <a:ext cx="10332720" cy="640080"/>
           </a:xfrm>
           <a:prstGeom prst="rect">
             <a:avLst/>
@@ -5907,13 +5907,13 @@
               </a:spcAft>
             </a:pPr>
             <a:r>
-              <a:rPr sz="1400" b="1" lang="en-US">
+              <a:rPr sz="1500" b="1" lang="en-US">
                 <a:solidFill>
                   <a:srgbClr val="0F6B4F"/>
                 </a:solidFill>
                 <a:latin typeface="Calibri"/>
               </a:rPr>
-              <a:t>Symmetric trust: both sides pass identity verification before the first deal.</a:t>
+              <a:t>Every user — requester and helper alike — passes identity verification before their first deal. Trust runs both ways.</a:t>
             </a:r>
           </a:p>
         </p:txBody>
@@ -6025,7 +6025,7 @@
                 </a:solidFill>
                 <a:latin typeface="Calibri"/>
               </a:rPr>
-              <a:t>§8 · Demo</a:t>
+              <a:t>§8 · Core processes</a:t>
             </a:r>
           </a:p>
         </p:txBody>
@@ -6103,13 +6103,13 @@
               </a:spcAft>
             </a:pPr>
             <a:r>
-              <a:rPr sz="3400" b="1" lang="en-US">
+              <a:rPr sz="3000" b="1" lang="en-US">
                 <a:solidFill>
                   <a:srgbClr val="FFFFFF"/>
                 </a:solidFill>
                 <a:latin typeface="Calibri"/>
               </a:rPr>
-              <a:t>Live demo — the core loop</a:t>
+              <a:t>Live demo — the whole journey, start to finish</a:t>
             </a:r>
           </a:p>
         </p:txBody>
@@ -6122,7 +6122,7 @@
         </p:nvSpPr>
         <p:spPr>
           <a:xfrm>
-            <a:off x="548640" y="1481328"/>
+            <a:off x="548640" y="1463040"/>
             <a:ext cx="11064240" cy="31750"/>
           </a:xfrm>
           <a:prstGeom prst="rect">
@@ -6226,7 +6226,7 @@
         </p:nvSpPr>
         <p:spPr>
           <a:xfrm>
-            <a:off x="1463040" y="1746504"/>
+            <a:off x="1463040" y="1728216"/>
             <a:ext cx="9921240" cy="411480"/>
           </a:xfrm>
           <a:prstGeom prst="rect">
@@ -6269,7 +6269,7 @@
         <p:spPr>
           <a:xfrm>
             <a:off x="1463040" y="2148840"/>
-            <a:ext cx="9921240" cy="365760"/>
+            <a:ext cx="9921240" cy="384048"/>
           </a:xfrm>
           <a:prstGeom prst="rect">
             <a:avLst/>
@@ -6291,13 +6291,13 @@
               </a:spcAft>
             </a:pPr>
             <a:r>
-              <a:rPr sz="1400" b="0" lang="en-US">
+              <a:rPr sz="1500" b="0" lang="en-US">
                 <a:solidFill>
                   <a:srgbClr val="D9E8E1"/>
                 </a:solidFill>
                 <a:latin typeface="Calibri"/>
               </a:rPr>
-              <a:t>Title, description, photo, location → status "open"</a:t>
+              <a:t>The requester writes what they need, adds a location, and posts. It appears in the feed as "open".</a:t>
             </a:r>
           </a:p>
         </p:txBody>
@@ -6310,7 +6310,7 @@
         </p:nvSpPr>
         <p:spPr>
           <a:xfrm>
-            <a:off x="640080" y="2679191"/>
+            <a:off x="640080" y="2697480"/>
             <a:ext cx="658368" cy="658368"/>
           </a:xfrm>
           <a:prstGeom prst="roundRect">
@@ -6370,7 +6370,7 @@
         </p:nvSpPr>
         <p:spPr>
           <a:xfrm>
-            <a:off x="1463040" y="2642615"/>
+            <a:off x="1463040" y="2642616"/>
             <a:ext cx="9921240" cy="411480"/>
           </a:xfrm>
           <a:prstGeom prst="rect">
@@ -6412,8 +6412,8 @@
         </p:nvSpPr>
         <p:spPr>
           <a:xfrm>
-            <a:off x="1463040" y="3044951"/>
-            <a:ext cx="9921240" cy="365760"/>
+            <a:off x="1463040" y="3063240"/>
+            <a:ext cx="9921240" cy="384048"/>
           </a:xfrm>
           <a:prstGeom prst="rect">
             <a:avLst/>
@@ -6435,13 +6435,13 @@
               </a:spcAft>
             </a:pPr>
             <a:r>
-              <a:rPr sz="1400" b="0" lang="en-US">
+              <a:rPr sz="1500" b="0" lang="en-US">
                 <a:solidFill>
                   <a:srgbClr val="D9E8E1"/>
                 </a:solidFill>
                 <a:latin typeface="Calibri"/>
               </a:rPr>
-              <a:t>Helper picks a pricing stance — sealed bid, no competitors seen</a:t>
+              <a:t>A helper sees the request and submits an offer with a price. They don't see the competitors' bids.</a:t>
             </a:r>
           </a:p>
         </p:txBody>
@@ -6454,7 +6454,7 @@
         </p:nvSpPr>
         <p:spPr>
           <a:xfrm>
-            <a:off x="640080" y="3575303"/>
+            <a:off x="640080" y="3611880"/>
             <a:ext cx="658368" cy="658368"/>
           </a:xfrm>
           <a:prstGeom prst="roundRect">
@@ -6514,7 +6514,7 @@
         </p:nvSpPr>
         <p:spPr>
           <a:xfrm>
-            <a:off x="1463040" y="3538727"/>
+            <a:off x="1463040" y="3557016"/>
             <a:ext cx="9921240" cy="411480"/>
           </a:xfrm>
           <a:prstGeom prst="rect">
@@ -6543,7 +6543,7 @@
                 </a:solidFill>
                 <a:latin typeface="Calibri"/>
               </a:rPr>
-              <a:t>Compare + assign</a:t>
+              <a:t>Compare and pick</a:t>
             </a:r>
           </a:p>
         </p:txBody>
@@ -6556,8 +6556,8 @@
         </p:nvSpPr>
         <p:spPr>
           <a:xfrm>
-            <a:off x="1463040" y="3941063"/>
-            <a:ext cx="9921240" cy="365760"/>
+            <a:off x="1463040" y="3977640"/>
+            <a:ext cx="9921240" cy="384048"/>
           </a:xfrm>
           <a:prstGeom prst="rect">
             <a:avLst/>
@@ -6579,13 +6579,13 @@
               </a:spcAft>
             </a:pPr>
             <a:r>
-              <a:rPr sz="1400" b="0" lang="en-US">
+              <a:rPr sz="1500" b="0" lang="en-US">
                 <a:solidFill>
                   <a:srgbClr val="D9E8E1"/>
                 </a:solidFill>
                 <a:latin typeface="Calibri"/>
               </a:rPr>
-              <a:t>Atomic assignment: closes all others in one transaction</a:t>
+              <a:t>The requester sees all offers together and picks one. All the rest close automatically.</a:t>
             </a:r>
           </a:p>
         </p:txBody>
@@ -6598,7 +6598,7 @@
         </p:nvSpPr>
         <p:spPr>
           <a:xfrm>
-            <a:off x="640080" y="4471416"/>
+            <a:off x="640080" y="4526280"/>
             <a:ext cx="658368" cy="658368"/>
           </a:xfrm>
           <a:prstGeom prst="roundRect">
@@ -6658,7 +6658,7 @@
         </p:nvSpPr>
         <p:spPr>
           <a:xfrm>
-            <a:off x="1463040" y="4434840"/>
+            <a:off x="1463040" y="4471416"/>
             <a:ext cx="9921240" cy="411480"/>
           </a:xfrm>
           <a:prstGeom prst="rect">
@@ -6687,7 +6687,7 @@
                 </a:solidFill>
                 <a:latin typeface="Calibri"/>
               </a:rPr>
-              <a:t>Dual completion</a:t>
+              <a:t>Both confirm</a:t>
             </a:r>
           </a:p>
         </p:txBody>
@@ -6700,8 +6700,8 @@
         </p:nvSpPr>
         <p:spPr>
           <a:xfrm>
-            <a:off x="1463040" y="4837176"/>
-            <a:ext cx="9921240" cy="365760"/>
+            <a:off x="1463040" y="4892040"/>
+            <a:ext cx="9921240" cy="384048"/>
           </a:xfrm>
           <a:prstGeom prst="rect">
             <a:avLst/>
@@ -6723,13 +6723,13 @@
               </a:spcAft>
             </a:pPr>
             <a:r>
-              <a:rPr sz="1400" b="0" lang="en-US">
+              <a:rPr sz="1500" b="0" lang="en-US">
                 <a:solidFill>
                   <a:srgbClr val="D9E8E1"/>
                 </a:solidFill>
                 <a:latin typeface="Calibri"/>
               </a:rPr>
-              <a:t>Both sides confirm → only then "completed"</a:t>
+              <a:t>Both sides confirm the work is done — only then does the request close.</a:t>
             </a:r>
           </a:p>
         </p:txBody>
@@ -6742,7 +6742,7 @@
         </p:nvSpPr>
         <p:spPr>
           <a:xfrm>
-            <a:off x="640080" y="5367527"/>
+            <a:off x="640080" y="5440680"/>
             <a:ext cx="658368" cy="658368"/>
           </a:xfrm>
           <a:prstGeom prst="roundRect">
@@ -6802,7 +6802,7 @@
         </p:nvSpPr>
         <p:spPr>
           <a:xfrm>
-            <a:off x="1463040" y="5330951"/>
+            <a:off x="1463040" y="5385816"/>
             <a:ext cx="9921240" cy="411480"/>
           </a:xfrm>
           <a:prstGeom prst="rect">
@@ -6844,8 +6844,8 @@
         </p:nvSpPr>
         <p:spPr>
           <a:xfrm>
-            <a:off x="1463040" y="5733288"/>
-            <a:ext cx="9921240" cy="365760"/>
+            <a:off x="1463040" y="5806440"/>
+            <a:ext cx="9921240" cy="384048"/>
           </a:xfrm>
           <a:prstGeom prst="rect">
             <a:avLst/>
@@ -6867,13 +6867,13 @@
               </a:spcAft>
             </a:pPr>
             <a:r>
-              <a:rPr sz="1400" b="0" lang="en-US">
+              <a:rPr sz="1500" b="0" lang="en-US">
                 <a:solidFill>
                   <a:srgbClr val="D9E8E1"/>
                 </a:solidFill>
                 <a:latin typeface="Calibri"/>
               </a:rPr>
-              <a:t>The requester rates → the reputation page updates</a:t>
+              <a:t>The requester rates the helper, saved to their public profile.</a:t>
             </a:r>
           </a:p>
         </p:txBody>
@@ -7063,13 +7063,13 @@
               </a:spcAft>
             </a:pPr>
             <a:r>
-              <a:rPr sz="3400" b="1" lang="en-US">
+              <a:rPr sz="3200" b="1" lang="en-US">
                 <a:solidFill>
                   <a:srgbClr val="0E1F18"/>
                 </a:solidFill>
                 <a:latin typeface="Calibri"/>
               </a:rPr>
-              <a:t>Architecture: the database is the authority</a:t>
+              <a:t>Architecture: the database is the boss</a:t>
             </a:r>
           </a:p>
         </p:txBody>
@@ -7082,7 +7082,7 @@
         </p:nvSpPr>
         <p:spPr>
           <a:xfrm>
-            <a:off x="548640" y="1481328"/>
+            <a:off x="548640" y="1463040"/>
             <a:ext cx="11064240" cy="31750"/>
           </a:xfrm>
           <a:prstGeom prst="rect">
@@ -7126,8 +7126,8 @@
         </p:nvSpPr>
         <p:spPr>
           <a:xfrm>
-            <a:off x="640080" y="1783080"/>
-            <a:ext cx="10881360" cy="3931920"/>
+            <a:off x="640080" y="1737360"/>
+            <a:ext cx="10881360" cy="3749039"/>
           </a:xfrm>
           <a:prstGeom prst="rect">
             <a:avLst/>
@@ -7145,17 +7145,17 @@
                 <a:spcPts val="0"/>
               </a:spcBef>
               <a:spcAft>
-                <a:spcPts val="1600"/>
-              </a:spcAft>
-            </a:pPr>
-            <a:r>
-              <a:rPr sz="1400" b="1">
+                <a:spcPts val="1500"/>
+              </a:spcAft>
+            </a:pPr>
+            <a:r>
+              <a:rPr sz="1300" b="1">
                 <a:solidFill>
                   <a:srgbClr val="0F6B4F"/>
                 </a:solidFill>
                 <a:latin typeface="Calibri"/>
               </a:rPr>
-              <a:t>●  </a:t>
+              <a:t>●   </a:t>
             </a:r>
             <a:r>
               <a:rPr sz="1800">
@@ -7164,7 +7164,7 @@
                 </a:solidFill>
                 <a:latin typeface="Calibri"/>
               </a:rPr>
-              <a:t>Three tiers: React · Next.js on Vercel · Supabase (Postgres + RLS, Auth, Storage).</a:t>
+              <a:t>The system has three parts: the browser the user sees, a Next.js server running in the cloud (Vercel), and a Supabase database.</a:t>
             </a:r>
           </a:p>
           <a:p>
@@ -7173,17 +7173,17 @@
                 <a:spcPts val="0"/>
               </a:spcBef>
               <a:spcAft>
-                <a:spcPts val="1600"/>
-              </a:spcAft>
-            </a:pPr>
-            <a:r>
-              <a:rPr sz="1400" b="1">
+                <a:spcPts val="1500"/>
+              </a:spcAft>
+            </a:pPr>
+            <a:r>
+              <a:rPr sz="1300" b="1">
                 <a:solidFill>
                   <a:srgbClr val="0F6B4F"/>
                 </a:solidFill>
                 <a:latin typeface="Calibri"/>
               </a:rPr>
-              <a:t>●  </a:t>
+              <a:t>●   </a:t>
             </a:r>
             <a:r>
               <a:rPr sz="1800">
@@ -7192,7 +7192,7 @@
                 </a:solidFill>
                 <a:latin typeface="Calibri"/>
               </a:rPr>
-              <a:t>Reads = Server Components · writes = Server Actions · no separate API server.</a:t>
+              <a:t>The core idea: every rule about 'who can do what' is enforced inside the database itself — not in the website's code.</a:t>
             </a:r>
           </a:p>
           <a:p>
@@ -7201,17 +7201,17 @@
                 <a:spcPts val="0"/>
               </a:spcBef>
               <a:spcAft>
-                <a:spcPts val="1600"/>
-              </a:spcAft>
-            </a:pPr>
-            <a:r>
-              <a:rPr sz="1400" b="1">
+                <a:spcPts val="1500"/>
+              </a:spcAft>
+            </a:pPr>
+            <a:r>
+              <a:rPr sz="1300" b="1">
                 <a:solidFill>
                   <a:srgbClr val="0F6B4F"/>
                 </a:solidFill>
                 <a:latin typeface="Calibri"/>
               </a:rPr>
-              <a:t>●  </a:t>
+              <a:t>●   </a:t>
             </a:r>
             <a:r>
               <a:rPr sz="1800">
@@ -7220,7 +7220,7 @@
                 </a:solidFill>
                 <a:latin typeface="Calibri"/>
               </a:rPr>
-              <a:t>Every permission enforced in Postgres: RLS + 11 SECURITY DEFINER functions + triggers.</a:t>
+              <a:t>Why does that matter? Because even if someone tries to bypass the site and talk to the database directly — the database refuses them.</a:t>
             </a:r>
           </a:p>
           <a:p>
@@ -7229,17 +7229,17 @@
                 <a:spcPts val="0"/>
               </a:spcBef>
               <a:spcAft>
-                <a:spcPts val="1600"/>
-              </a:spcAft>
-            </a:pPr>
-            <a:r>
-              <a:rPr sz="1400" b="1">
+                <a:spcPts val="1500"/>
+              </a:spcAft>
+            </a:pPr>
+            <a:r>
+              <a:rPr sz="1300" b="1">
                 <a:solidFill>
                   <a:srgbClr val="0F6B4F"/>
                 </a:solidFill>
                 <a:latin typeface="Calibri"/>
               </a:rPr>
-              <a:t>●  </a:t>
+              <a:t>●   </a:t>
             </a:r>
             <a:r>
               <a:rPr sz="1800">
@@ -7248,7 +7248,7 @@
                 </a:solidFill>
                 <a:latin typeface="Calibri"/>
               </a:rPr>
-              <a:t>The app never uses the service-role key.</a:t>
+              <a:t>The site's code only shows friendly messages. The real security sits one layer deeper, in the database.</a:t>
             </a:r>
           </a:p>
         </p:txBody>
@@ -7261,8 +7261,8 @@
         </p:nvSpPr>
         <p:spPr>
           <a:xfrm>
-            <a:off x="640080" y="5623560"/>
-            <a:ext cx="10881360" cy="731520"/>
+            <a:off x="640080" y="5577840"/>
+            <a:ext cx="10881360" cy="777240"/>
           </a:xfrm>
           <a:prstGeom prst="roundRect">
             <a:avLst/>
@@ -7305,8 +7305,8 @@
         </p:nvSpPr>
         <p:spPr>
           <a:xfrm>
-            <a:off x="914400" y="5705856"/>
-            <a:ext cx="10332720" cy="566928"/>
+            <a:off x="914400" y="5650992"/>
+            <a:ext cx="10332720" cy="640080"/>
           </a:xfrm>
           <a:prstGeom prst="rect">
             <a:avLst/>
@@ -7328,13 +7328,13 @@
               </a:spcAft>
             </a:pPr>
             <a:r>
-              <a:rPr sz="1400" b="1" lang="en-US">
+              <a:rPr sz="1500" b="1" lang="en-US">
                 <a:solidFill>
                   <a:srgbClr val="0F6B4F"/>
                 </a:solidFill>
                 <a:latin typeface="Calibri"/>
               </a:rPr>
-              <a:t>The key decision: the profiles/profiles_private split — RLS is row-level.</a:t>
+              <a:t>The decision I'm proudest of: I split private data (phone, location) into a separate table only its owner can read.</a:t>
             </a:r>
           </a:p>
         </p:txBody>
@@ -7446,7 +7446,7 @@
                 </a:solidFill>
                 <a:latin typeface="Calibri"/>
               </a:rPr>
-              <a:t>§7 · Database</a:t>
+              <a:t>§7 · The database</a:t>
             </a:r>
           </a:p>
         </p:txBody>
@@ -7524,13 +7524,13 @@
               </a:spcAft>
             </a:pPr>
             <a:r>
-              <a:rPr sz="3400" b="1" lang="en-US">
+              <a:rPr sz="3200" b="1" lang="en-US">
                 <a:solidFill>
                   <a:srgbClr val="0E1F18"/>
                 </a:solidFill>
                 <a:latin typeface="Calibri"/>
               </a:rPr>
-              <a:t>The database</a:t>
+              <a:t>How the database is built</a:t>
             </a:r>
           </a:p>
         </p:txBody>
@@ -7543,7 +7543,7 @@
         </p:nvSpPr>
         <p:spPr>
           <a:xfrm>
-            <a:off x="548640" y="1481328"/>
+            <a:off x="548640" y="1463040"/>
             <a:ext cx="11064240" cy="31750"/>
           </a:xfrm>
           <a:prstGeom prst="rect">
@@ -7587,8 +7587,8 @@
         </p:nvSpPr>
         <p:spPr>
           <a:xfrm>
-            <a:off x="640080" y="1783080"/>
-            <a:ext cx="10881360" cy="3931920"/>
+            <a:off x="640080" y="1737360"/>
+            <a:ext cx="10881360" cy="3749039"/>
           </a:xfrm>
           <a:prstGeom prst="rect">
             <a:avLst/>
@@ -7606,26 +7606,26 @@
                 <a:spcPts val="0"/>
               </a:spcBef>
               <a:spcAft>
-                <a:spcPts val="1700"/>
-              </a:spcAft>
-            </a:pPr>
-            <a:r>
-              <a:rPr sz="1500" b="1">
+                <a:spcPts val="1500"/>
+              </a:spcAft>
+            </a:pPr>
+            <a:r>
+              <a:rPr sz="1300" b="1">
                 <a:solidFill>
                   <a:srgbClr val="0F6B4F"/>
                 </a:solidFill>
                 <a:latin typeface="Calibri"/>
               </a:rPr>
-              <a:t>●  </a:t>
-            </a:r>
-            <a:r>
-              <a:rPr sz="1900">
+              <a:t>●   </a:t>
+            </a:r>
+            <a:r>
+              <a:rPr sz="1800">
                 <a:solidFill>
                   <a:srgbClr val="0E1F18"/>
                 </a:solidFill>
                 <a:latin typeface="Calibri"/>
               </a:rPr>
-              <a:t>7 tables · 14 SQL migrations — the source of truth.</a:t>
+              <a:t>There are 7 tables: users, requests, offers, ratings, verifications, and more — all linked together.</a:t>
             </a:r>
           </a:p>
           <a:p>
@@ -7634,26 +7634,26 @@
                 <a:spcPts val="0"/>
               </a:spcBef>
               <a:spcAft>
-                <a:spcPts val="1700"/>
-              </a:spcAft>
-            </a:pPr>
-            <a:r>
-              <a:rPr sz="1500" b="1">
+                <a:spcPts val="1500"/>
+              </a:spcAft>
+            </a:pPr>
+            <a:r>
+              <a:rPr sz="1300" b="1">
                 <a:solidFill>
                   <a:srgbClr val="0F6B4F"/>
                 </a:solidFill>
                 <a:latin typeface="Calibri"/>
               </a:rPr>
-              <a:t>●  </a:t>
-            </a:r>
-            <a:r>
-              <a:rPr sz="1900">
+              <a:t>●   </a:t>
+            </a:r>
+            <a:r>
+              <a:rPr sz="1800">
                 <a:solidFill>
                   <a:srgbClr val="0E1F18"/>
                 </a:solidFill>
                 <a:latin typeface="Calibri"/>
               </a:rPr>
-              <a:t>State machine: open → has_offers → assigned → completed → rated.</a:t>
+              <a:t>Every request has a fixed 'life path': open → has offers → assigned → completed → rated.</a:t>
             </a:r>
           </a:p>
           <a:p>
@@ -7662,26 +7662,26 @@
                 <a:spcPts val="0"/>
               </a:spcBef>
               <a:spcAft>
-                <a:spcPts val="1700"/>
-              </a:spcAft>
-            </a:pPr>
-            <a:r>
-              <a:rPr sz="1500" b="1">
+                <a:spcPts val="1500"/>
+              </a:spcAft>
+            </a:pPr>
+            <a:r>
+              <a:rPr sz="1300" b="1">
                 <a:solidFill>
                   <a:srgbClr val="0F6B4F"/>
                 </a:solidFill>
                 <a:latin typeface="Calibri"/>
               </a:rPr>
-              <a:t>●  </a:t>
-            </a:r>
-            <a:r>
-              <a:rPr sz="1900">
+              <a:t>●   </a:t>
+            </a:r>
+            <a:r>
+              <a:rPr sz="1800">
                 <a:solidFill>
                   <a:srgbClr val="0E1F18"/>
                 </a:solidFill>
                 <a:latin typeface="Calibri"/>
               </a:rPr>
-              <a:t>Enums for closed value-sets → an invalid state becomes a type error.</a:t>
+              <a:t>This path is enforced in the database — you can't skip a step or go back illegally.</a:t>
             </a:r>
           </a:p>
           <a:p>
@@ -7690,26 +7690,26 @@
                 <a:spcPts val="0"/>
               </a:spcBef>
               <a:spcAft>
-                <a:spcPts val="1700"/>
-              </a:spcAft>
-            </a:pPr>
-            <a:r>
-              <a:rPr sz="1500" b="1">
+                <a:spcPts val="1500"/>
+              </a:spcAft>
+            </a:pPr>
+            <a:r>
+              <a:rPr sz="1300" b="1">
                 <a:solidFill>
                   <a:srgbClr val="0F6B4F"/>
                 </a:solidFill>
                 <a:latin typeface="Calibri"/>
               </a:rPr>
-              <a:t>●  </a:t>
-            </a:r>
-            <a:r>
-              <a:rPr sz="1900">
+              <a:t>●   </a:t>
+            </a:r>
+            <a:r>
+              <a:rPr sz="1800">
                 <a:solidFill>
                   <a:srgbClr val="0E1F18"/>
                 </a:solidFill>
                 <a:latin typeface="Calibri"/>
               </a:rPr>
-              <a:t>An index per hot query · every RLS policy carries its justification.</a:t>
+              <a:t>Every permission rule in the database comes with a comment explaining exactly which product rule it protects.</a:t>
             </a:r>
           </a:p>
         </p:txBody>
@@ -7722,8 +7722,8 @@
         </p:nvSpPr>
         <p:spPr>
           <a:xfrm>
-            <a:off x="640080" y="5623560"/>
-            <a:ext cx="10881360" cy="731520"/>
+            <a:off x="640080" y="5577840"/>
+            <a:ext cx="10881360" cy="777240"/>
           </a:xfrm>
           <a:prstGeom prst="roundRect">
             <a:avLst/>
@@ -7766,8 +7766,8 @@
         </p:nvSpPr>
         <p:spPr>
           <a:xfrm>
-            <a:off x="914400" y="5705856"/>
-            <a:ext cx="10332720" cy="566928"/>
+            <a:off x="914400" y="5650992"/>
+            <a:ext cx="10332720" cy="640080"/>
           </a:xfrm>
           <a:prstGeom prst="rect">
             <a:avLst/>
@@ -7789,13 +7789,13 @@
               </a:spcAft>
             </a:pPr>
             <a:r>
-              <a:rPr sz="1400" b="1" lang="en-US">
+              <a:rPr sz="1500" b="1" lang="en-US">
                 <a:solidFill>
                   <a:srgbClr val="0F6B4F"/>
                 </a:solidFill>
                 <a:latin typeface="Calibri"/>
               </a:rPr>
-              <a:t>Example: sealed bids — only the offer owner and request owner can read it.</a:t>
+              <a:t>Example: a helper's offer is visible only to them and the requester. No other helper sees the competing bids.</a:t>
             </a:r>
           </a:p>
         </p:txBody>
@@ -7907,7 +7907,7 @@
                 </a:solidFill>
                 <a:latin typeface="Calibri"/>
               </a:rPr>
-              <a:t>§9 · Tests</a:t>
+              <a:t>§9 · Testing</a:t>
             </a:r>
           </a:p>
         </p:txBody>
@@ -7985,13 +7985,13 @@
               </a:spcAft>
             </a:pPr>
             <a:r>
-              <a:rPr sz="3400" b="1" lang="en-US">
+              <a:rPr sz="3200" b="1" lang="en-US">
                 <a:solidFill>
                   <a:srgbClr val="0E1F18"/>
                 </a:solidFill>
                 <a:latin typeface="Calibri"/>
               </a:rPr>
-              <a:t>Tests: proving the database says "no"</a:t>
+              <a:t>Testing: proving the system is really secure</a:t>
             </a:r>
           </a:p>
         </p:txBody>
@@ -8004,7 +8004,7 @@
         </p:nvSpPr>
         <p:spPr>
           <a:xfrm>
-            <a:off x="548640" y="1481328"/>
+            <a:off x="548640" y="1463040"/>
             <a:ext cx="11064240" cy="31750"/>
           </a:xfrm>
           <a:prstGeom prst="rect">
@@ -8048,8 +8048,8 @@
         </p:nvSpPr>
         <p:spPr>
           <a:xfrm>
-            <a:off x="640080" y="1783080"/>
-            <a:ext cx="10881360" cy="3931920"/>
+            <a:off x="640080" y="1737360"/>
+            <a:ext cx="10881360" cy="3749039"/>
           </a:xfrm>
           <a:prstGeom prst="rect">
             <a:avLst/>
@@ -8067,26 +8067,26 @@
                 <a:spcPts val="0"/>
               </a:spcBef>
               <a:spcAft>
-                <a:spcPts val="1700"/>
-              </a:spcAft>
-            </a:pPr>
-            <a:r>
-              <a:rPr sz="1500" b="1">
+                <a:spcPts val="1500"/>
+              </a:spcAft>
+            </a:pPr>
+            <a:r>
+              <a:rPr sz="1300" b="1">
                 <a:solidFill>
                   <a:srgbClr val="0F6B4F"/>
                 </a:solidFill>
                 <a:latin typeface="Calibri"/>
               </a:rPr>
-              <a:t>●  </a:t>
-            </a:r>
-            <a:r>
-              <a:rPr sz="1900">
+              <a:t>●   </a:t>
+            </a:r>
+            <a:r>
+              <a:rPr sz="1800">
                 <a:solidFill>
                   <a:srgbClr val="0E1F18"/>
                 </a:solidFill>
                 <a:latin typeface="Calibri"/>
               </a:rPr>
-              <a:t>62 automated tests (61 Vitest + Playwright E2E) — all passing.</a:t>
+              <a:t>I wrote 62 automated tests that run against the system, and they all pass.</a:t>
             </a:r>
           </a:p>
           <a:p>
@@ -8095,26 +8095,26 @@
                 <a:spcPts val="0"/>
               </a:spcBef>
               <a:spcAft>
-                <a:spcPts val="1700"/>
-              </a:spcAft>
-            </a:pPr>
-            <a:r>
-              <a:rPr sz="1500" b="1">
+                <a:spcPts val="1500"/>
+              </a:spcAft>
+            </a:pPr>
+            <a:r>
+              <a:rPr sz="1300" b="1">
                 <a:solidFill>
                   <a:srgbClr val="0F6B4F"/>
                 </a:solidFill>
                 <a:latin typeface="Calibri"/>
               </a:rPr>
-              <a:t>●  </a:t>
-            </a:r>
-            <a:r>
-              <a:rPr sz="1900">
+              <a:t>●   </a:t>
+            </a:r>
+            <a:r>
+              <a:rPr sz="1800">
                 <a:solidFill>
                   <a:srgbClr val="0E1F18"/>
                 </a:solidFill>
                 <a:latin typeface="Calibri"/>
               </a:rPr>
-              <a:t>15 permission tests attack the DB as the wrong user and assert denial.</a:t>
+              <a:t>The most interesting tests try to break in: they impersonate an unauthorized user and attempt a forbidden action.</a:t>
             </a:r>
           </a:p>
           <a:p>
@@ -8123,26 +8123,26 @@
                 <a:spcPts val="0"/>
               </a:spcBef>
               <a:spcAft>
-                <a:spcPts val="1700"/>
-              </a:spcAft>
-            </a:pPr>
-            <a:r>
-              <a:rPr sz="1500" b="1">
+                <a:spcPts val="1500"/>
+              </a:spcAft>
+            </a:pPr>
+            <a:r>
+              <a:rPr sz="1300" b="1">
                 <a:solidFill>
                   <a:srgbClr val="0F6B4F"/>
                 </a:solidFill>
                 <a:latin typeface="Calibri"/>
               </a:rPr>
-              <a:t>●  </a:t>
-            </a:r>
-            <a:r>
-              <a:rPr sz="1900">
+              <a:t>●   </a:t>
+            </a:r>
+            <a:r>
+              <a:rPr sz="1800">
                 <a:solidFill>
                   <a:srgbClr val="0E1F18"/>
                 </a:solidFill>
                 <a:latin typeface="Calibri"/>
               </a:rPr>
-              <a:t>A happy-path-only test proves nothing — we assert denial too.</a:t>
+              <a:t>A test that only checks things work isn't enough — I also check the system blocks whoever shouldn't get in.</a:t>
             </a:r>
           </a:p>
           <a:p>
@@ -8151,26 +8151,26 @@
                 <a:spcPts val="0"/>
               </a:spcBef>
               <a:spcAft>
-                <a:spcPts val="1700"/>
-              </a:spcAft>
-            </a:pPr>
-            <a:r>
-              <a:rPr sz="1500" b="1">
+                <a:spcPts val="1500"/>
+              </a:spcAft>
+            </a:pPr>
+            <a:r>
+              <a:rPr sz="1300" b="1">
                 <a:solidFill>
                   <a:srgbClr val="0F6B4F"/>
                 </a:solidFill>
                 <a:latin typeface="Calibri"/>
               </a:rPr>
-              <a:t>●  </a:t>
-            </a:r>
-            <a:r>
-              <a:rPr sz="1900">
+              <a:t>●   </a:t>
+            </a:r>
+            <a:r>
+              <a:rPr sz="1800">
                 <a:solidFill>
                   <a:srgbClr val="0E1F18"/>
                 </a:solidFill>
                 <a:latin typeface="Calibri"/>
               </a:rPr>
-              <a:t>A full E2E drives the whole loop in two separate browser sessions.</a:t>
+              <a:t>There's also a test that runs the whole journey — post, offer, pick, finish — in two browsers at once, like real users.</a:t>
             </a:r>
           </a:p>
         </p:txBody>
@@ -8183,8 +8183,8 @@
         </p:nvSpPr>
         <p:spPr>
           <a:xfrm>
-            <a:off x="640080" y="5623560"/>
-            <a:ext cx="10881360" cy="731520"/>
+            <a:off x="640080" y="5577840"/>
+            <a:ext cx="10881360" cy="777240"/>
           </a:xfrm>
           <a:prstGeom prst="roundRect">
             <a:avLst/>
@@ -8227,8 +8227,8 @@
         </p:nvSpPr>
         <p:spPr>
           <a:xfrm>
-            <a:off x="914400" y="5705856"/>
-            <a:ext cx="10332720" cy="566928"/>
+            <a:off x="914400" y="5650992"/>
+            <a:ext cx="10332720" cy="640080"/>
           </a:xfrm>
           <a:prstGeom prst="rect">
             <a:avLst/>
@@ -8250,13 +8250,13 @@
               </a:spcAft>
             </a:pPr>
             <a:r>
-              <a:rPr sz="1400" b="1" lang="en-US">
+              <a:rPr sz="1500" b="1" lang="en-US">
                 <a:solidFill>
                   <a:srgbClr val="0F6B4F"/>
                 </a:solidFill>
                 <a:latin typeface="Calibri"/>
               </a:rPr>
-              <a:t>The tests are organized around the security claim: the database enforces every rule.</a:t>
+              <a:t>All the tests are built around the core claim: the database enforces every rule, even against someone trying to cheat.</a:t>
             </a:r>
           </a:p>
         </p:txBody>
@@ -8446,13 +8446,13 @@
               </a:spcAft>
             </a:pPr>
             <a:r>
-              <a:rPr sz="3400" b="1" lang="en-US">
+              <a:rPr sz="3200" b="1" lang="en-US">
                 <a:solidFill>
                   <a:srgbClr val="0E1F18"/>
                 </a:solidFill>
                 <a:latin typeface="Calibri"/>
               </a:rPr>
-              <a:t>How we thought about scale</a:t>
+              <a:t>How the system handles many users</a:t>
             </a:r>
           </a:p>
         </p:txBody>
@@ -8465,7 +8465,7 @@
         </p:nvSpPr>
         <p:spPr>
           <a:xfrm>
-            <a:off x="548640" y="1481328"/>
+            <a:off x="548640" y="1463040"/>
             <a:ext cx="11064240" cy="31750"/>
           </a:xfrm>
           <a:prstGeom prst="rect">
@@ -8509,8 +8509,8 @@
         </p:nvSpPr>
         <p:spPr>
           <a:xfrm>
-            <a:off x="640080" y="1783080"/>
-            <a:ext cx="10881360" cy="3931920"/>
+            <a:off x="640080" y="1645920"/>
+            <a:ext cx="10881360" cy="640080"/>
           </a:xfrm>
           <a:prstGeom prst="rect">
             <a:avLst/>
@@ -8518,7 +8518,7 @@
           <a:noFill/>
         </p:spPr>
         <p:txBody>
-          <a:bodyPr wrap="square" lIns="50800" rIns="50800">
+          <a:bodyPr wrap="square" anchor="t" lIns="50800" rIns="50800" tIns="25400" bIns="25400">
             <a:spAutoFit/>
           </a:bodyPr>
           <a:lstStyle/>
@@ -8528,110 +8528,17 @@
                 <a:spcPts val="0"/>
               </a:spcBef>
               <a:spcAft>
-                <a:spcPts val="1700"/>
-              </a:spcAft>
-            </a:pPr>
-            <a:r>
-              <a:rPr sz="1500" b="1">
-                <a:solidFill>
-                  <a:srgbClr val="0F6B4F"/>
-                </a:solidFill>
-                <a:latin typeface="Calibri"/>
-              </a:rPr>
-              <a:t>●  </a:t>
-            </a:r>
-            <a:r>
-              <a:rPr sz="1900">
+                <a:spcPts val="0"/>
+              </a:spcAft>
+            </a:pPr>
+            <a:r>
+              <a:rPr sz="1700" b="0" lang="en-US">
                 <a:solidFill>
                   <a:srgbClr val="0E1F18"/>
                 </a:solidFill>
                 <a:latin typeface="Calibri"/>
               </a:rPr>
-              <a:t>Designed for tens of users and hundreds of requests — simple and correct.</a:t>
-            </a:r>
-          </a:p>
-          <a:p>
-            <a:pPr algn="l" rtl="0">
-              <a:spcBef>
-                <a:spcPts val="0"/>
-              </a:spcBef>
-              <a:spcAft>
-                <a:spcPts val="1700"/>
-              </a:spcAft>
-            </a:pPr>
-            <a:r>
-              <a:rPr sz="1500" b="1">
-                <a:solidFill>
-                  <a:srgbClr val="0F6B4F"/>
-                </a:solidFill>
-                <a:latin typeface="Calibri"/>
-              </a:rPr>
-              <a:t>●  </a:t>
-            </a:r>
-            <a:r>
-              <a:rPr sz="1900">
-                <a:solidFill>
-                  <a:srgbClr val="0E1F18"/>
-                </a:solidFill>
-                <a:latin typeface="Calibri"/>
-              </a:rPr>
-              <a:t>Feed capped at 200 + Haversine sort in TypeScript + 12 per page.</a:t>
-            </a:r>
-          </a:p>
-          <a:p>
-            <a:pPr algn="l" rtl="0">
-              <a:spcBef>
-                <a:spcPts val="0"/>
-              </a:spcBef>
-              <a:spcAft>
-                <a:spcPts val="1700"/>
-              </a:spcAft>
-            </a:pPr>
-            <a:r>
-              <a:rPr sz="1500" b="1">
-                <a:solidFill>
-                  <a:srgbClr val="0F6B4F"/>
-                </a:solidFill>
-                <a:latin typeface="Calibri"/>
-              </a:rPr>
-              <a:t>●  </a:t>
-            </a:r>
-            <a:r>
-              <a:rPr sz="1900">
-                <a:solidFill>
-                  <a:srgbClr val="0E1F18"/>
-                </a:solidFill>
-                <a:latin typeface="Calibri"/>
-              </a:rPr>
-              <a:t>An index per heavy query · server-side reads · no client cache.</a:t>
-            </a:r>
-          </a:p>
-          <a:p>
-            <a:pPr algn="l" rtl="0">
-              <a:spcBef>
-                <a:spcPts val="0"/>
-              </a:spcBef>
-              <a:spcAft>
-                <a:spcPts val="1700"/>
-              </a:spcAft>
-            </a:pPr>
-            <a:r>
-              <a:rPr sz="1500" b="1">
-                <a:solidFill>
-                  <a:srgbClr val="0F6B4F"/>
-                </a:solidFill>
-                <a:latin typeface="Calibri"/>
-              </a:rPr>
-              <a:t>●  </a:t>
-            </a:r>
-            <a:r>
-              <a:rPr sz="1900">
-                <a:solidFill>
-                  <a:srgbClr val="0E1F18"/>
-                </a:solidFill>
-                <a:latin typeface="Calibri"/>
-              </a:rPr>
-              <a:t>Every limit has an explicit signal and a named successor — all additive.</a:t>
+              <a:t>"Scale" is the question: what happens when 10 users become 10,000? Will the site stay fast?</a:t>
             </a:r>
           </a:p>
         </p:txBody>
@@ -8644,14 +8551,14 @@
         </p:nvSpPr>
         <p:spPr>
           <a:xfrm>
-            <a:off x="640080" y="5623560"/>
-            <a:ext cx="10881360" cy="731520"/>
+            <a:off x="640080" y="2514600"/>
+            <a:ext cx="5257800" cy="548640"/>
           </a:xfrm>
           <a:prstGeom prst="roundRect">
             <a:avLst/>
           </a:prstGeom>
           <a:solidFill>
-            <a:srgbClr val="EAF2EE"/>
+            <a:srgbClr val="0F6B4F"/>
           </a:solidFill>
           <a:ln>
             <a:noFill/>
@@ -8688,8 +8595,8 @@
         </p:nvSpPr>
         <p:spPr>
           <a:xfrm>
-            <a:off x="914400" y="5705856"/>
-            <a:ext cx="10332720" cy="566928"/>
+            <a:off x="640080" y="2578608"/>
+            <a:ext cx="5257800" cy="420624"/>
           </a:xfrm>
           <a:prstGeom prst="rect">
             <a:avLst/>
@@ -8702,22 +8609,322 @@
           </a:bodyPr>
           <a:lstStyle/>
           <a:p>
+            <a:pPr algn="ctr" rtl="0">
+              <a:spcBef>
+                <a:spcPts val="0"/>
+              </a:spcBef>
+              <a:spcAft>
+                <a:spcPts val="0"/>
+              </a:spcAft>
+            </a:pPr>
+            <a:r>
+              <a:rPr sz="1700" b="1" lang="en-US">
+                <a:solidFill>
+                  <a:srgbClr val="FFFFFF"/>
+                </a:solidFill>
+                <a:latin typeface="Calibri"/>
+              </a:rPr>
+              <a:t>Already built for growth</a:t>
+            </a:r>
+          </a:p>
+        </p:txBody>
+      </p:sp>
+      <p:sp>
+        <p:nvSpPr>
+          <p:cNvPr id="10" name="TextBox 9"/>
+          <p:cNvSpPr txBox="1"/>
+          <p:nvPr/>
+        </p:nvSpPr>
+        <p:spPr>
+          <a:xfrm>
+            <a:off x="640080" y="3291840"/>
+            <a:ext cx="5257800" cy="2743200"/>
+          </a:xfrm>
+          <a:prstGeom prst="rect">
+            <a:avLst/>
+          </a:prstGeom>
+          <a:noFill/>
+        </p:spPr>
+        <p:txBody>
+          <a:bodyPr wrap="square" lIns="50800" rIns="50800">
+            <a:spAutoFit/>
+          </a:bodyPr>
+          <a:lstStyle/>
+          <a:p>
             <a:pPr algn="l" rtl="0">
               <a:spcBef>
                 <a:spcPts val="0"/>
               </a:spcBef>
               <a:spcAft>
-                <a:spcPts val="0"/>
-              </a:spcAft>
-            </a:pPr>
-            <a:r>
-              <a:rPr sz="1400" b="1" lang="en-US">
+                <a:spcPts val="1300"/>
+              </a:spcAft>
+            </a:pPr>
+            <a:r>
+              <a:rPr sz="1000" b="1">
                 <a:solidFill>
                   <a:srgbClr val="0F6B4F"/>
                 </a:solidFill>
                 <a:latin typeface="Calibri"/>
               </a:rPr>
-              <a:t>What breaks first is the human admin queue, not the DB — and we say so honestly.</a:t>
+              <a:t>●   </a:t>
+            </a:r>
+            <a:r>
+              <a:rPr sz="1500">
+                <a:solidFill>
+                  <a:srgbClr val="0E1F18"/>
+                </a:solidFill>
+                <a:latin typeface="Calibri"/>
+              </a:rPr>
+              <a:t>The feed loads only 200 requests at a time, not all of them — so it never chokes.</a:t>
+            </a:r>
+          </a:p>
+          <a:p>
+            <a:pPr algn="l" rtl="0">
+              <a:spcBef>
+                <a:spcPts val="0"/>
+              </a:spcBef>
+              <a:spcAft>
+                <a:spcPts val="1300"/>
+              </a:spcAft>
+            </a:pPr>
+            <a:r>
+              <a:rPr sz="1000" b="1">
+                <a:solidFill>
+                  <a:srgbClr val="0F6B4F"/>
+                </a:solidFill>
+                <a:latin typeface="Calibri"/>
+              </a:rPr>
+              <a:t>●   </a:t>
+            </a:r>
+            <a:r>
+              <a:rPr sz="1500">
+                <a:solidFill>
+                  <a:srgbClr val="0E1F18"/>
+                </a:solidFill>
+                <a:latin typeface="Calibri"/>
+              </a:rPr>
+              <a:t>It shows 12 requests per page, with paging — not everything at once.</a:t>
+            </a:r>
+          </a:p>
+          <a:p>
+            <a:pPr algn="l" rtl="0">
+              <a:spcBef>
+                <a:spcPts val="0"/>
+              </a:spcBef>
+              <a:spcAft>
+                <a:spcPts val="1300"/>
+              </a:spcAft>
+            </a:pPr>
+            <a:r>
+              <a:rPr sz="1000" b="1">
+                <a:solidFill>
+                  <a:srgbClr val="0F6B4F"/>
+                </a:solidFill>
+                <a:latin typeface="Calibri"/>
+              </a:rPr>
+              <a:t>●   </a:t>
+            </a:r>
+            <a:r>
+              <a:rPr sz="1500">
+                <a:solidFill>
+                  <a:srgbClr val="0E1F18"/>
+                </a:solidFill>
+                <a:latin typeface="Calibri"/>
+              </a:rPr>
+              <a:t>The database has 'indexes' — like the alphabetical order in a phone book — to find things fast.</a:t>
+            </a:r>
+          </a:p>
+        </p:txBody>
+      </p:sp>
+      <p:sp>
+        <p:nvSpPr>
+          <p:cNvPr id="11" name="Rounded Rectangle 10"/>
+          <p:cNvSpPr/>
+          <p:nvPr/>
+        </p:nvSpPr>
+        <p:spPr>
+          <a:xfrm>
+            <a:off x="6263640" y="2514600"/>
+            <a:ext cx="5257800" cy="548640"/>
+          </a:xfrm>
+          <a:prstGeom prst="roundRect">
+            <a:avLst/>
+          </a:prstGeom>
+          <a:solidFill>
+            <a:srgbClr val="8A9890"/>
+          </a:solidFill>
+          <a:ln>
+            <a:noFill/>
+          </a:ln>
+          <a:effectLst/>
+        </p:spPr>
+        <p:style>
+          <a:lnRef idx="1">
+            <a:schemeClr val="accent1"/>
+          </a:lnRef>
+          <a:fillRef idx="3">
+            <a:schemeClr val="accent1"/>
+          </a:fillRef>
+          <a:effectRef idx="2">
+            <a:schemeClr val="accent1"/>
+          </a:effectRef>
+          <a:fontRef idx="minor">
+            <a:schemeClr val="lt1"/>
+          </a:fontRef>
+        </p:style>
+        <p:txBody>
+          <a:bodyPr rtlCol="0" anchor="ctr"/>
+          <a:lstStyle/>
+          <a:p>
+            <a:pPr algn="ctr"/>
+          </a:p>
+        </p:txBody>
+      </p:sp>
+      <p:sp>
+        <p:nvSpPr>
+          <p:cNvPr id="12" name="TextBox 11"/>
+          <p:cNvSpPr txBox="1"/>
+          <p:nvPr/>
+        </p:nvSpPr>
+        <p:spPr>
+          <a:xfrm>
+            <a:off x="6263640" y="2578608"/>
+            <a:ext cx="5257800" cy="420624"/>
+          </a:xfrm>
+          <a:prstGeom prst="rect">
+            <a:avLst/>
+          </a:prstGeom>
+          <a:noFill/>
+        </p:spPr>
+        <p:txBody>
+          <a:bodyPr wrap="square" anchor="ctr" lIns="50800" rIns="50800" tIns="25400" bIns="25400">
+            <a:spAutoFit/>
+          </a:bodyPr>
+          <a:lstStyle/>
+          <a:p>
+            <a:pPr algn="ctr" rtl="0">
+              <a:spcBef>
+                <a:spcPts val="0"/>
+              </a:spcBef>
+              <a:spcAft>
+                <a:spcPts val="0"/>
+              </a:spcAft>
+            </a:pPr>
+            <a:r>
+              <a:rPr sz="1700" b="1" lang="en-US">
+                <a:solidFill>
+                  <a:srgbClr val="FFFFFF"/>
+                </a:solidFill>
+                <a:latin typeface="Calibri"/>
+              </a:rPr>
+              <a:t>What I'd improve at scale</a:t>
+            </a:r>
+          </a:p>
+        </p:txBody>
+      </p:sp>
+      <p:sp>
+        <p:nvSpPr>
+          <p:cNvPr id="13" name="TextBox 12"/>
+          <p:cNvSpPr txBox="1"/>
+          <p:nvPr/>
+        </p:nvSpPr>
+        <p:spPr>
+          <a:xfrm>
+            <a:off x="6263640" y="3291840"/>
+            <a:ext cx="5257800" cy="2743200"/>
+          </a:xfrm>
+          <a:prstGeom prst="rect">
+            <a:avLst/>
+          </a:prstGeom>
+          <a:noFill/>
+        </p:spPr>
+        <p:txBody>
+          <a:bodyPr wrap="square" lIns="50800" rIns="50800">
+            <a:spAutoFit/>
+          </a:bodyPr>
+          <a:lstStyle/>
+          <a:p>
+            <a:pPr algn="l" rtl="0">
+              <a:spcBef>
+                <a:spcPts val="0"/>
+              </a:spcBef>
+              <a:spcAft>
+                <a:spcPts val="1300"/>
+              </a:spcAft>
+            </a:pPr>
+            <a:r>
+              <a:rPr sz="1000" b="1">
+                <a:solidFill>
+                  <a:srgbClr val="0F6B4F"/>
+                </a:solidFill>
+                <a:latin typeface="Calibri"/>
+              </a:rPr>
+              <a:t>●   </a:t>
+            </a:r>
+            <a:r>
+              <a:rPr sz="1500">
+                <a:solidFill>
+                  <a:srgbClr val="0E1F18"/>
+                </a:solidFill>
+                <a:latin typeface="Calibri"/>
+              </a:rPr>
+              <a:t>Distance calculation would move into the database, to support millions of requests.</a:t>
+            </a:r>
+          </a:p>
+          <a:p>
+            <a:pPr algn="l" rtl="0">
+              <a:spcBef>
+                <a:spcPts val="0"/>
+              </a:spcBef>
+              <a:spcAft>
+                <a:spcPts val="1300"/>
+              </a:spcAft>
+            </a:pPr>
+            <a:r>
+              <a:rPr sz="1000" b="1">
+                <a:solidFill>
+                  <a:srgbClr val="0F6B4F"/>
+                </a:solidFill>
+                <a:latin typeface="Calibri"/>
+              </a:rPr>
+              <a:t>●   </a:t>
+            </a:r>
+            <a:r>
+              <a:rPr sz="1500">
+                <a:solidFill>
+                  <a:srgbClr val="0E1F18"/>
+                </a:solidFill>
+                <a:latin typeface="Calibri"/>
+              </a:rPr>
+              <a:t>Automatic verification (SMS) instead of an admin approving each user by hand.</a:t>
+            </a:r>
+          </a:p>
+          <a:p>
+            <a:pPr algn="l" rtl="0">
+              <a:spcBef>
+                <a:spcPts val="0"/>
+              </a:spcBef>
+              <a:spcAft>
+                <a:spcPts val="1300"/>
+              </a:spcAft>
+            </a:pPr>
+            <a:r>
+              <a:rPr sz="1000" b="1">
+                <a:solidFill>
+                  <a:srgbClr val="0F6B4F"/>
+                </a:solidFill>
+                <a:latin typeface="Calibri"/>
+              </a:rPr>
+              <a:t>●   </a:t>
+            </a:r>
+            <a:r>
+              <a:rPr sz="1500">
+                <a:solidFill>
+                  <a:srgbClr val="0E1F18"/>
+                </a:solidFill>
+                <a:latin typeface="Calibri"/>
+              </a:rPr>
+              <a:t>Because what breaks first isn't the computer — it's the human approving by hand.</a:t>
             </a:r>
           </a:p>
         </p:txBody>

</xml_diff>